<commit_message>
feat: round 21 deliverables - machine receipt of round 20 baked in + Chinese usage section (docx 9 sections / pptx 8 slides)
Co-authored-by: arena-agent <297053741+arena-agent@users.noreply.github.com>
</commit_message>
<xml_diff>
--- a/deliverable/LINK_PROOF_v2.8.1.pptx
+++ b/deliverable/LINK_PROOF_v2.8.1.pptx
@@ -11,6 +11,8 @@
     <p:sldId id="259" r:id="rId10"/>
     <p:sldId id="260" r:id="rId11"/>
     <p:sldId id="261" r:id="rId12"/>
+    <p:sldId id="262" r:id="rId13"/>
+    <p:sldId id="263" r:id="rId14"/>
   </p:sldIdLst>
   <p:sldSz cx="9144000" cy="6858000" type="screen4x3"/>
   <p:notesSz cx="6858000" cy="9144000"/>
@@ -3574,6 +3576,180 @@
             </a:pPr>
             <a:r>
               <a:t>no fake local side: no local/inbox, no stand-in skill</a:t>
+            </a:r>
+          </a:p>
+        </p:txBody>
+      </p:sp>
+    </p:spTree>
+  </p:cSld>
+  <p:clrMapOvr>
+    <a:masterClrMapping/>
+  </p:clrMapOvr>
+</p:sld>
+</file>
+
+<file path=ppt/slides/slide7.xml><?xml version="1.0" encoding="utf-8"?>
+<p:sld xmlns:a="http://schemas.openxmlformats.org/drawingml/2006/main" xmlns:p="http://schemas.openxmlformats.org/presentationml/2006/main" xmlns:r="http://schemas.openxmlformats.org/officeDocument/2006/relationships">
+  <p:cSld>
+    <p:spTree>
+      <p:nvGrpSpPr>
+        <p:cNvPr id="1" name=""/>
+        <p:cNvGrpSpPr/>
+        <p:nvPr/>
+      </p:nvGrpSpPr>
+      <p:grpSpPr/>
+      <p:sp>
+        <p:nvSpPr>
+          <p:cNvPr id="2" name="Title 1"/>
+          <p:cNvSpPr>
+            <a:spLocks noGrp="1"/>
+          </p:cNvSpPr>
+          <p:nvPr>
+            <p:ph type="title"/>
+          </p:nvPr>
+        </p:nvSpPr>
+        <p:spPr/>
+        <p:txBody>
+          <a:bodyPr/>
+          <a:lstStyle/>
+          <a:p>
+            <a:r>
+              <a:t>本机回执 / machine receipt (round 20)</a:t>
+            </a:r>
+          </a:p>
+        </p:txBody>
+      </p:sp>
+      <p:sp>
+        <p:nvSpPr>
+          <p:cNvPr id="3" name="Content Placeholder 2"/>
+          <p:cNvSpPr>
+            <a:spLocks noGrp="1"/>
+          </p:cNvSpPr>
+          <p:nvPr>
+            <p:ph idx="1"/>
+          </p:nvPr>
+        </p:nvSpPr>
+        <p:spPr/>
+        <p:txBody>
+          <a:bodyPr/>
+          <a:lstStyle/>
+          <a:p>
+            <a:pPr>
+              <a:defRPr sz="1600"/>
+            </a:pPr>
+            <a:r>
+              <a:t>round 20 在 LAPTOP-R77M5D6M 判定 passed（exit 0，21 秒）</a:t>
+            </a:r>
+          </a:p>
+          <a:p>
+            <a:pPr>
+              <a:defRPr sz="1600"/>
+            </a:pPr>
+            <a:r>
+              <a:t>3a-3g 全 OK：哈希/字节、必需部件、XML、关系、内容类型、标记词、页数 6 &gt;= 6</a:t>
+            </a:r>
+          </a:p>
+          <a:p>
+            <a:pPr>
+              <a:defRPr sz="1600"/>
+            </a:pPr>
+            <a:r>
+              <a:t>3h：真 Word 只读打开 .docx；真 PowerPoint 只读打开 .pptx（6 页）</a:t>
+            </a:r>
+          </a:p>
+          <a:p>
+            <a:pPr>
+              <a:defRPr sz="1600"/>
+            </a:pPr>
+            <a:r>
+              <a:t>本机还跑了真 PowerShell 解析器逐个解析 .ps1（沙箱只能 SKIP）</a:t>
+            </a:r>
+          </a:p>
+        </p:txBody>
+      </p:sp>
+    </p:spTree>
+  </p:cSld>
+  <p:clrMapOvr>
+    <a:masterClrMapping/>
+  </p:clrMapOvr>
+</p:sld>
+</file>
+
+<file path=ppt/slides/slide8.xml><?xml version="1.0" encoding="utf-8"?>
+<p:sld xmlns:a="http://schemas.openxmlformats.org/drawingml/2006/main" xmlns:p="http://schemas.openxmlformats.org/presentationml/2006/main" xmlns:r="http://schemas.openxmlformats.org/officeDocument/2006/relationships">
+  <p:cSld>
+    <p:spTree>
+      <p:nvGrpSpPr>
+        <p:cNvPr id="1" name=""/>
+        <p:cNvGrpSpPr/>
+        <p:nvPr/>
+      </p:nvGrpSpPr>
+      <p:grpSpPr/>
+      <p:sp>
+        <p:nvSpPr>
+          <p:cNvPr id="2" name="Title 1"/>
+          <p:cNvSpPr>
+            <a:spLocks noGrp="1"/>
+          </p:cNvSpPr>
+          <p:nvPr>
+            <p:ph type="title"/>
+          </p:nvPr>
+        </p:nvSpPr>
+        <p:spPr/>
+        <p:txBody>
+          <a:bodyPr/>
+          <a:lstStyle/>
+          <a:p>
+            <a:r>
+              <a:t>中文说明：这条链路怎么用</a:t>
+            </a:r>
+          </a:p>
+        </p:txBody>
+      </p:sp>
+      <p:sp>
+        <p:nvSpPr>
+          <p:cNvPr id="3" name="Content Placeholder 2"/>
+          <p:cNvSpPr>
+            <a:spLocks noGrp="1"/>
+          </p:cNvSpPr>
+          <p:nvPr>
+            <p:ph idx="1"/>
+          </p:nvPr>
+        </p:nvSpPr>
+        <p:spPr/>
+        <p:txBody>
+          <a:bodyPr/>
+          <a:lstStyle/>
+          <a:p>
+            <a:pPr>
+              <a:defRPr sz="1600"/>
+            </a:pPr>
+            <a:r>
+              <a:t>链路：Arena 会话（沙箱）↔ 你的 Windows 本机，中间只有 git</a:t>
+            </a:r>
+          </a:p>
+          <a:p>
+            <a:pPr>
+              <a:defRPr sz="1600"/>
+            </a:pPr>
+            <a:r>
+              <a:t>本机只做一次：clone 新文件夹 → .\bootstrap.ps1 -Auto（注册值守 + 免点击推送）</a:t>
+            </a:r>
+          </a:p>
+          <a:p>
+            <a:pPr>
+              <a:defRPr sz="1600"/>
+            </a:pPr>
+            <a:r>
+              <a:t>值守每 2 分钟：自动 pull → 跑 code\local_check.ps1 → 把结论和日志推回分支</a:t>
+            </a:r>
+          </a:p>
+          <a:p>
+            <a:pPr>
+              <a:defRPr sz="1600"/>
+            </a:pPr>
+            <a:r>
+              <a:t>取产物：.\download.ps1 -Set final；看结论：results/status/handshake.json 与 check_rN_*.txt</a:t>
             </a:r>
           </a:p>
         </p:txBody>

</xml_diff>